<commit_message>
Reflow imdb examples with complete originals first
</commit_message>
<xml_diff>
--- a/slides/datasets-in-10-minutes-imdb.pptx
+++ b/slides/datasets-in-10-minutes-imdb.pptx
@@ -7807,28 +7807,20 @@
           </a:bodyPr>
           <a:lstStyle/>
           <a:p>
-            <a:pPr algn="l">
-              <a:lnSpc>
-                <a:spcPct val="110000"/>
-              </a:lnSpc>
-              <a:buNone/>
-              <a:defRPr sz="2800" b="0">
-                <a:solidFill>
-                  <a:srgbClr val="303437"/>
-                </a:solidFill>
-                <a:latin typeface="Noto Sans"/>
-              </a:defRPr>
-            </a:pPr>
-            <a:r>
-              <a:rPr sz="2800" b="1" lang="ja-JP" altLang="en-US">
-                <a:solidFill>
-                  <a:srgbClr val="303437"/>
-                </a:solidFill>
-                <a:latin typeface="Noto Sans"/>
-                <a:ea typeface="Noto Sans CJK JP"/>
-                <a:cs typeface="Noto Sans"/>
-              </a:rPr>
-              <a:t>実例2：好きな点があっても否定的（2/2）</a:t>
+            <a:pPr>
+              <a:lnSpc>
+                <a:spcPts val="3247"/>
+              </a:lnSpc>
+            </a:pPr>
+            <a:r>
+              <a:rPr sz="2800" b="1">
+                <a:solidFill>
+                  <a:srgbClr val="303437"/>
+                </a:solidFill>
+                <a:latin typeface="Noto Sans"/>
+                <a:ea typeface="Noto Sans CJK JP"/>
+              </a:rPr>
+              <a:t>実例2：好きな点があっても否定的（日本語訳）</a:t>
             </a:r>
           </a:p>
         </p:txBody>
@@ -7883,14 +7875,14 @@
       </p:sp>
       <p:sp>
         <p:nvSpPr>
-          <p:cNvPr id="4" name="TextBox 3"/>
+          <p:cNvPr id="7" name="sources"/>
           <p:cNvSpPr txBox="1"/>
           <p:nvPr/>
         </p:nvSpPr>
         <p:spPr>
           <a:xfrm>
-            <a:off x="548640" y="1344168"/>
-            <a:ext cx="8046720" cy="192024"/>
+            <a:off x="502920" y="4700016"/>
+            <a:ext cx="8183879" cy="530352"/>
           </a:xfrm>
           <a:prstGeom prst="rect">
             <a:avLst/>
@@ -7905,24 +7897,24 @@
           <a:p>
             <a:pPr algn="l">
               <a:lnSpc>
-                <a:spcPct val="117000"/>
-              </a:lnSpc>
-              <a:spcBef>
-                <a:spcPts val="0"/>
-              </a:spcBef>
-              <a:spcAft>
-                <a:spcPts val="0"/>
-              </a:spcAft>
-              <a:buNone/>
-              <a:defRPr sz="1250" b="0">
-                <a:solidFill>
-                  <a:srgbClr val="303437"/>
-                </a:solidFill>
-                <a:latin typeface="Noto Sans"/>
-              </a:defRPr>
-            </a:pPr>
-            <a:r>
-              <a:rPr sz="1250" b="0" lang="ja-JP" altLang="en-US">
+                <a:spcPts val="940"/>
+              </a:lnSpc>
+              <a:spcBef>
+                <a:spcPts val="0"/>
+              </a:spcBef>
+              <a:spcAft>
+                <a:spcPts val="140"/>
+              </a:spcAft>
+              <a:buNone/>
+              <a:defRPr sz="810" b="0">
+                <a:solidFill>
+                  <a:srgbClr val="303437"/>
+                </a:solidFill>
+                <a:latin typeface="Noto Sans"/>
+              </a:defRPr>
+            </a:pPr>
+            <a:r>
+              <a:rPr sz="810" b="0" lang="ja-JP" altLang="en-US">
                 <a:solidFill>
                   <a:srgbClr val="626669"/>
                 </a:solidFill>
@@ -7930,95 +7922,44 @@
                 <a:ea typeface="Noto Sans CJK JP"/>
                 <a:cs typeface="Noto Sans"/>
               </a:rPr>
-              <a:t>レビュー（後半）／原文と日本語訳</a:t>
-            </a:r>
-          </a:p>
-        </p:txBody>
-      </p:sp>
-      <p:sp>
-        <p:nvSpPr>
-          <p:cNvPr id="5" name="quote-frame"/>
-          <p:cNvSpPr/>
-          <p:nvPr/>
-        </p:nvSpPr>
-        <p:spPr>
-          <a:xfrm>
-            <a:off x="548640" y="1600200"/>
-            <a:ext cx="8046720" cy="813181"/>
-          </a:xfrm>
-          <a:prstGeom prst="rect">
-            <a:avLst/>
-          </a:prstGeom>
-          <a:solidFill>
-            <a:srgbClr val="EBEDEB"/>
-          </a:solidFill>
-          <a:ln>
-            <a:noFill/>
-          </a:ln>
-          <a:effectLst/>
-        </p:spPr>
-        <p:style>
-          <a:lnRef idx="1">
-            <a:schemeClr val="accent1"/>
-          </a:lnRef>
-          <a:fillRef idx="3">
-            <a:schemeClr val="accent1"/>
-          </a:fillRef>
-          <a:effectRef idx="0">
-            <a:schemeClr val="accent1"/>
-          </a:effectRef>
-          <a:fontRef idx="minor">
-            <a:schemeClr val="lt1"/>
-          </a:fontRef>
-        </p:style>
-        <p:txBody>
-          <a:bodyPr rtlCol="0" anchor="ctr" wrap="square" lIns="177800" rIns="177800" tIns="101600" bIns="127000">
-            <a:noAutofit/>
-          </a:bodyPr>
-          <a:lstStyle/>
-          <a:p>
-            <a:pPr algn="l">
-              <a:lnSpc>
-                <a:spcPts val="2201"/>
-              </a:lnSpc>
-              <a:spcBef>
-                <a:spcPts val="0"/>
-              </a:spcBef>
-              <a:spcAft>
-                <a:spcPts val="0"/>
-              </a:spcAft>
-              <a:buNone/>
-              <a:defRPr sz="1850" b="0">
-                <a:solidFill>
-                  <a:srgbClr val="303437"/>
-                </a:solidFill>
-                <a:latin typeface="Noto Sans"/>
-              </a:defRPr>
-            </a:pPr>
-            <a:r>
-              <a:rPr sz="1850" b="0" lang="ja-JP" altLang="en-US">
-                <a:solidFill>
-                  <a:srgbClr val="303437"/>
-                </a:solidFill>
-                <a:latin typeface="Noto Sans"/>
-                <a:ea typeface="Noto Sans CJK JP"/>
-                <a:cs typeface="Noto Sans"/>
-              </a:rPr>
-              <a:t>I especially like the old hotel they used to shoot this in, it added to what little suspense was mustered. Give it a 3.</a:t>
-            </a:r>
-          </a:p>
-        </p:txBody>
-      </p:sp>
-      <p:sp>
-        <p:nvSpPr>
-          <p:cNvPr id="6" name="TextBox 5"/>
+              <a:t>[1] stanfordnlp/imdb、改訂e6281661。2026-10-17参照。 testの0始まり行 61。</a:t>
+            </a:r>
+            <a:r>
+              <a:rPr sz="810" b="0" lang="ja-JP" altLang="en-US">
+                <a:solidFill>
+                  <a:srgbClr val="626669"/>
+                </a:solidFill>
+                <a:latin typeface="Noto Sans"/>
+                <a:ea typeface="Noto Sans CJK JP"/>
+                <a:cs typeface="Noto Sans"/>
+              </a:rPr>
+              <a:t>  </a:t>
+            </a:r>
+            <a:r>
+              <a:rPr sz="810" b="0" lang="ja-JP" altLang="en-US">
+                <a:solidFill>
+                  <a:srgbClr val="626669"/>
+                </a:solidFill>
+                <a:latin typeface="Noto Sans"/>
+                <a:ea typeface="Noto Sans CJK JP"/>
+                <a:cs typeface="Noto Sans"/>
+                <a:hlinkClick r:id="rId2"/>
+              </a:rPr>
+              <a:t>https://huggingface.co/datasets/stanfordnlp/imdb</a:t>
+            </a:r>
+          </a:p>
+        </p:txBody>
+      </p:sp>
+      <p:sp>
+        <p:nvSpPr>
+          <p:cNvPr id="8" name="example-answer"/>
           <p:cNvSpPr txBox="1"/>
           <p:nvPr/>
         </p:nvSpPr>
         <p:spPr>
           <a:xfrm>
-            <a:off x="594360" y="2468245"/>
-            <a:ext cx="7955279" cy="595757"/>
+            <a:off x="4434840" y="1216152"/>
+            <a:ext cx="4114800" cy="384048"/>
           </a:xfrm>
           <a:prstGeom prst="rect">
             <a:avLst/>
@@ -8026,53 +7967,47 @@
           <a:noFill/>
         </p:spPr>
         <p:txBody>
-          <a:bodyPr wrap="square" lIns="0" rIns="0" tIns="0" bIns="0">
+          <a:bodyPr wrap="none" lIns="0" rIns="0" tIns="0" bIns="0">
             <a:noAutofit/>
           </a:bodyPr>
           <a:lstStyle/>
           <a:p>
-            <a:pPr algn="l">
-              <a:lnSpc>
-                <a:spcPct val="119000"/>
-              </a:lnSpc>
-              <a:spcBef>
-                <a:spcPts val="0"/>
-              </a:spcBef>
-              <a:spcAft>
-                <a:spcPts val="0"/>
-              </a:spcAft>
-              <a:buNone/>
-              <a:defRPr sz="1850" b="0">
-                <a:solidFill>
-                  <a:srgbClr val="303437"/>
-                </a:solidFill>
-                <a:latin typeface="Noto Sans"/>
-              </a:defRPr>
-            </a:pPr>
-            <a:r>
-              <a:rPr sz="1850" b="0" lang="ja-JP" altLang="en-US">
-                <a:solidFill>
-                  <a:srgbClr val="303437"/>
-                </a:solidFill>
-                <a:latin typeface="Noto Sans"/>
-                <a:ea typeface="Noto Sans CJK JP"/>
-                <a:cs typeface="Noto Sans"/>
-              </a:rPr>
-              <a:t>特に撮影に使われた古いホテルが好きで、わずかな緊張感を高めていた。評価は3点。</a:t>
-            </a:r>
-          </a:p>
-        </p:txBody>
-      </p:sp>
-      <p:sp>
-        <p:nvSpPr>
-          <p:cNvPr id="7" name="sources"/>
+            <a:pPr algn="r">
+              <a:lnSpc>
+                <a:spcPts val="2640"/>
+              </a:lnSpc>
+              <a:spcBef>
+                <a:spcPts val="0"/>
+              </a:spcBef>
+              <a:spcAft>
+                <a:spcPts val="0"/>
+              </a:spcAft>
+              <a:buNone/>
+            </a:pPr>
+            <a:r>
+              <a:rPr sz="2200" b="1" lang="ja-JP">
+                <a:solidFill>
+                  <a:schemeClr val="accent1"/>
+                </a:solidFill>
+                <a:latin typeface="Noto Sans"/>
+                <a:ea typeface="Noto Sans CJK JP"/>
+                <a:cs typeface="Noto Sans"/>
+              </a:rPr>
+              <a:t>正解：Negative（否定的）</a:t>
+            </a:r>
+          </a:p>
+        </p:txBody>
+      </p:sp>
+      <p:sp>
+        <p:nvSpPr>
+          <p:cNvPr id="9" name="translation-label"/>
           <p:cNvSpPr txBox="1"/>
           <p:nvPr/>
         </p:nvSpPr>
         <p:spPr>
           <a:xfrm>
-            <a:off x="502920" y="4700016"/>
-            <a:ext cx="8183879" cy="530352"/>
+            <a:off x="548640" y="1399032"/>
+            <a:ext cx="4572000" cy="201168"/>
           </a:xfrm>
           <a:prstGeom prst="rect">
             <a:avLst/>
@@ -8085,26 +8020,20 @@
           </a:bodyPr>
           <a:lstStyle/>
           <a:p>
-            <a:pPr algn="l">
-              <a:lnSpc>
-                <a:spcPts val="940"/>
-              </a:lnSpc>
-              <a:spcBef>
-                <a:spcPts val="0"/>
-              </a:spcBef>
-              <a:spcAft>
-                <a:spcPts val="140"/>
-              </a:spcAft>
-              <a:buNone/>
-              <a:defRPr sz="810" b="0">
-                <a:solidFill>
-                  <a:srgbClr val="303437"/>
-                </a:solidFill>
-                <a:latin typeface="Noto Sans"/>
-              </a:defRPr>
-            </a:pPr>
-            <a:r>
-              <a:rPr sz="810" b="0" lang="ja-JP" altLang="en-US">
+            <a:pPr>
+              <a:lnSpc>
+                <a:spcPts val="1464"/>
+              </a:lnSpc>
+              <a:spcBef>
+                <a:spcPts val="0"/>
+              </a:spcBef>
+              <a:spcAft>
+                <a:spcPts val="0"/>
+              </a:spcAft>
+              <a:buNone/>
+            </a:pPr>
+            <a:r>
+              <a:rPr sz="1200" b="0" lang="ja-JP">
                 <a:solidFill>
                   <a:srgbClr val="626669"/>
                 </a:solidFill>
@@ -8112,30 +8041,80 @@
                 <a:ea typeface="Noto Sans CJK JP"/>
                 <a:cs typeface="Noto Sans"/>
               </a:rPr>
-              <a:t>[1] stanfordnlp/imdb、改訂e6281661。2026-10-17参照。 testの0始まり行 61。</a:t>
-            </a:r>
-            <a:r>
-              <a:rPr sz="810" b="0" lang="ja-JP" altLang="en-US">
-                <a:solidFill>
-                  <a:srgbClr val="626669"/>
-                </a:solidFill>
-                <a:latin typeface="Noto Sans"/>
-                <a:ea typeface="Noto Sans CJK JP"/>
-                <a:cs typeface="Noto Sans"/>
-              </a:rPr>
-              <a:t>  </a:t>
-            </a:r>
-            <a:r>
-              <a:rPr sz="810" b="0" lang="ja-JP" altLang="en-US">
-                <a:solidFill>
-                  <a:srgbClr val="626669"/>
-                </a:solidFill>
-                <a:latin typeface="Noto Sans"/>
-                <a:ea typeface="Noto Sans CJK JP"/>
-                <a:cs typeface="Noto Sans"/>
-                <a:hlinkClick r:id="rId2"/>
-              </a:rPr>
-              <a:t>https://huggingface.co/datasets/stanfordnlp/imdb</a:t>
+              <a:t>日本語訳</a:t>
+            </a:r>
+          </a:p>
+        </p:txBody>
+      </p:sp>
+      <p:sp>
+        <p:nvSpPr>
+          <p:cNvPr id="10" name="translation-body"/>
+          <p:cNvSpPr txBox="1"/>
+          <p:nvPr/>
+        </p:nvSpPr>
+        <p:spPr>
+          <a:xfrm>
+            <a:off x="594360" y="1655064"/>
+            <a:ext cx="7955279" cy="1431925"/>
+          </a:xfrm>
+          <a:prstGeom prst="rect">
+            <a:avLst/>
+          </a:prstGeom>
+          <a:noFill/>
+        </p:spPr>
+        <p:txBody>
+          <a:bodyPr wrap="square" lIns="0" rIns="0" tIns="0" bIns="0">
+            <a:noAutofit/>
+          </a:bodyPr>
+          <a:lstStyle/>
+          <a:p>
+            <a:pPr>
+              <a:lnSpc>
+                <a:spcPts val="2135"/>
+              </a:lnSpc>
+              <a:spcBef>
+                <a:spcPts val="0"/>
+              </a:spcBef>
+              <a:spcAft>
+                <a:spcPts val="0"/>
+              </a:spcAft>
+              <a:buNone/>
+            </a:pPr>
+            <a:r>
+              <a:rPr sz="1750" b="0" lang="ja-JP">
+                <a:solidFill>
+                  <a:srgbClr val="303437"/>
+                </a:solidFill>
+                <a:latin typeface="Noto Sans"/>
+                <a:ea typeface="Noto Sans CJK JP"/>
+                <a:cs typeface="Noto Sans"/>
+              </a:rPr>
+              <a:t>レビュー：この映画には、好きだが人には少し言いにくい楽しみが二つある。確かに特殊効果は笑ってしまう出来で、話も混乱しているが、『ナイトライダー』時代のハッセルホフを見るだけでも楽しい。</a:t>
+            </a:r>
+          </a:p>
+          <a:p>
+            <a:pPr>
+              <a:lnSpc>
+                <a:spcPts val="2135"/>
+              </a:lnSpc>
+              <a:spcBef>
+                <a:spcPts val="0"/>
+              </a:spcBef>
+              <a:spcAft>
+                <a:spcPts val="0"/>
+              </a:spcAft>
+              <a:buNone/>
+            </a:pPr>
+            <a:r>
+              <a:rPr sz="1750" b="0" lang="ja-JP">
+                <a:solidFill>
+                  <a:srgbClr val="303437"/>
+                </a:solidFill>
+                <a:latin typeface="Noto Sans"/>
+                <a:ea typeface="Noto Sans CJK JP"/>
+                <a:cs typeface="Noto Sans"/>
+              </a:rPr>
+              <a:t>レビュー：特に撮影に使われた古いホテルが好きで、わずかな緊張感を高めていた。評価は3点。</a:t>
             </a:r>
           </a:p>
         </p:txBody>
@@ -25414,28 +25393,20 @@
           </a:bodyPr>
           <a:lstStyle/>
           <a:p>
-            <a:pPr algn="l">
-              <a:lnSpc>
-                <a:spcPct val="110000"/>
-              </a:lnSpc>
-              <a:buNone/>
-              <a:defRPr sz="2800" b="0">
-                <a:solidFill>
-                  <a:srgbClr val="303437"/>
-                </a:solidFill>
-                <a:latin typeface="Noto Sans"/>
-              </a:defRPr>
-            </a:pPr>
-            <a:r>
-              <a:rPr sz="2800" b="1" lang="ja-JP" altLang="en-US">
-                <a:solidFill>
-                  <a:srgbClr val="303437"/>
-                </a:solidFill>
-                <a:latin typeface="Noto Sans"/>
-                <a:ea typeface="Noto Sans CJK JP"/>
-                <a:cs typeface="Noto Sans"/>
-              </a:rPr>
-              <a:t>実例2：好きな点があっても否定的（1/2）</a:t>
+            <a:pPr>
+              <a:lnSpc>
+                <a:spcPts val="3247"/>
+              </a:lnSpc>
+            </a:pPr>
+            <a:r>
+              <a:rPr sz="2800" b="1">
+                <a:solidFill>
+                  <a:srgbClr val="303437"/>
+                </a:solidFill>
+                <a:latin typeface="Noto Sans"/>
+                <a:ea typeface="Noto Sans CJK JP"/>
+              </a:rPr>
+              <a:t>実例2：好きな点があっても否定的（原文）</a:t>
             </a:r>
           </a:p>
         </p:txBody>
@@ -25490,14 +25461,14 @@
       </p:sp>
       <p:sp>
         <p:nvSpPr>
-          <p:cNvPr id="4" name="TextBox 3"/>
+          <p:cNvPr id="7" name="sources"/>
           <p:cNvSpPr txBox="1"/>
           <p:nvPr/>
         </p:nvSpPr>
         <p:spPr>
           <a:xfrm>
-            <a:off x="548640" y="1344168"/>
-            <a:ext cx="8046720" cy="192024"/>
+            <a:off x="502920" y="4700016"/>
+            <a:ext cx="8183879" cy="530352"/>
           </a:xfrm>
           <a:prstGeom prst="rect">
             <a:avLst/>
@@ -25512,24 +25483,24 @@
           <a:p>
             <a:pPr algn="l">
               <a:lnSpc>
-                <a:spcPct val="117000"/>
-              </a:lnSpc>
-              <a:spcBef>
-                <a:spcPts val="0"/>
-              </a:spcBef>
-              <a:spcAft>
-                <a:spcPts val="0"/>
-              </a:spcAft>
-              <a:buNone/>
-              <a:defRPr sz="1250" b="0">
-                <a:solidFill>
-                  <a:srgbClr val="303437"/>
-                </a:solidFill>
-                <a:latin typeface="Noto Sans"/>
-              </a:defRPr>
-            </a:pPr>
-            <a:r>
-              <a:rPr sz="1250" b="0" lang="ja-JP" altLang="en-US">
+                <a:spcPts val="940"/>
+              </a:lnSpc>
+              <a:spcBef>
+                <a:spcPts val="0"/>
+              </a:spcBef>
+              <a:spcAft>
+                <a:spcPts val="140"/>
+              </a:spcAft>
+              <a:buNone/>
+              <a:defRPr sz="810" b="0">
+                <a:solidFill>
+                  <a:srgbClr val="303437"/>
+                </a:solidFill>
+                <a:latin typeface="Noto Sans"/>
+              </a:defRPr>
+            </a:pPr>
+            <a:r>
+              <a:rPr sz="810" b="0" lang="ja-JP" altLang="en-US">
                 <a:solidFill>
                   <a:srgbClr val="626669"/>
                 </a:solidFill>
@@ -25537,21 +25508,140 @@
                 <a:ea typeface="Noto Sans CJK JP"/>
                 <a:cs typeface="Noto Sans"/>
               </a:rPr>
-              <a:t>レビュー（前半）／原文と日本語訳</a:t>
-            </a:r>
-          </a:p>
-        </p:txBody>
-      </p:sp>
-      <p:sp>
-        <p:nvSpPr>
-          <p:cNvPr id="5" name="quote-frame"/>
-          <p:cNvSpPr/>
+              <a:t>[1] stanfordnlp/imdb、改訂e6281661。2026-10-17参照。 testの0始まり行 61。</a:t>
+            </a:r>
+            <a:r>
+              <a:rPr sz="810" b="0" lang="ja-JP" altLang="en-US">
+                <a:solidFill>
+                  <a:srgbClr val="626669"/>
+                </a:solidFill>
+                <a:latin typeface="Noto Sans"/>
+                <a:ea typeface="Noto Sans CJK JP"/>
+                <a:cs typeface="Noto Sans"/>
+              </a:rPr>
+              <a:t>  </a:t>
+            </a:r>
+            <a:r>
+              <a:rPr sz="810" b="0" lang="ja-JP" altLang="en-US">
+                <a:solidFill>
+                  <a:srgbClr val="626669"/>
+                </a:solidFill>
+                <a:latin typeface="Noto Sans"/>
+                <a:ea typeface="Noto Sans CJK JP"/>
+                <a:cs typeface="Noto Sans"/>
+                <a:hlinkClick r:id="rId2"/>
+              </a:rPr>
+              <a:t>https://huggingface.co/datasets/stanfordnlp/imdb</a:t>
+            </a:r>
+          </a:p>
+        </p:txBody>
+      </p:sp>
+      <p:sp>
+        <p:nvSpPr>
+          <p:cNvPr id="8" name="example-answer"/>
+          <p:cNvSpPr txBox="1"/>
           <p:nvPr/>
         </p:nvSpPr>
         <p:spPr>
           <a:xfrm>
-            <a:off x="548640" y="1600200"/>
-            <a:ext cx="8046720" cy="1092771"/>
+            <a:off x="4434840" y="1216152"/>
+            <a:ext cx="4114800" cy="384048"/>
+          </a:xfrm>
+          <a:prstGeom prst="rect">
+            <a:avLst/>
+          </a:prstGeom>
+          <a:noFill/>
+        </p:spPr>
+        <p:txBody>
+          <a:bodyPr wrap="none" lIns="0" rIns="0" tIns="0" bIns="0">
+            <a:noAutofit/>
+          </a:bodyPr>
+          <a:lstStyle/>
+          <a:p>
+            <a:pPr algn="r">
+              <a:lnSpc>
+                <a:spcPts val="2640"/>
+              </a:lnSpc>
+              <a:spcBef>
+                <a:spcPts val="0"/>
+              </a:spcBef>
+              <a:spcAft>
+                <a:spcPts val="0"/>
+              </a:spcAft>
+              <a:buNone/>
+            </a:pPr>
+            <a:r>
+              <a:rPr sz="2200" b="1" lang="ja-JP">
+                <a:solidFill>
+                  <a:schemeClr val="accent1"/>
+                </a:solidFill>
+                <a:latin typeface="Noto Sans"/>
+                <a:ea typeface="Noto Sans CJK JP"/>
+                <a:cs typeface="Noto Sans"/>
+              </a:rPr>
+              <a:t>正解：Negative（否定的）</a:t>
+            </a:r>
+          </a:p>
+        </p:txBody>
+      </p:sp>
+      <p:sp>
+        <p:nvSpPr>
+          <p:cNvPr id="9" name="original-label"/>
+          <p:cNvSpPr txBox="1"/>
+          <p:nvPr/>
+        </p:nvSpPr>
+        <p:spPr>
+          <a:xfrm>
+            <a:off x="548640" y="1399032"/>
+            <a:ext cx="4572000" cy="201168"/>
+          </a:xfrm>
+          <a:prstGeom prst="rect">
+            <a:avLst/>
+          </a:prstGeom>
+          <a:noFill/>
+        </p:spPr>
+        <p:txBody>
+          <a:bodyPr wrap="square" lIns="0" rIns="0" tIns="0" bIns="0">
+            <a:noAutofit/>
+          </a:bodyPr>
+          <a:lstStyle/>
+          <a:p>
+            <a:pPr>
+              <a:lnSpc>
+                <a:spcPts val="1464"/>
+              </a:lnSpc>
+              <a:spcBef>
+                <a:spcPts val="0"/>
+              </a:spcBef>
+              <a:spcAft>
+                <a:spcPts val="0"/>
+              </a:spcAft>
+              <a:buNone/>
+            </a:pPr>
+            <a:r>
+              <a:rPr sz="1200" b="0" lang="ja-JP">
+                <a:solidFill>
+                  <a:srgbClr val="626669"/>
+                </a:solidFill>
+                <a:latin typeface="Noto Sans"/>
+                <a:ea typeface="Noto Sans CJK JP"/>
+                <a:cs typeface="Noto Sans"/>
+              </a:rPr>
+              <a:t>原文</a:t>
+            </a:r>
+          </a:p>
+        </p:txBody>
+      </p:sp>
+      <p:sp>
+        <p:nvSpPr>
+          <p:cNvPr id="10" name="original-panel"/>
+          <p:cNvSpPr txBox="1"/>
+          <p:nvPr/>
+        </p:nvSpPr>
+        <p:spPr>
+          <a:xfrm>
+            <a:off x="548640" y="1655064"/>
+            <a:ext cx="8046720" cy="1687195"/>
           </a:xfrm>
           <a:prstGeom prst="rect">
             <a:avLst/>
@@ -25562,48 +25652,27 @@
           <a:ln>
             <a:noFill/>
           </a:ln>
-          <a:effectLst/>
-        </p:spPr>
-        <p:style>
-          <a:lnRef idx="1">
-            <a:schemeClr val="accent1"/>
-          </a:lnRef>
-          <a:fillRef idx="3">
-            <a:schemeClr val="accent1"/>
-          </a:fillRef>
-          <a:effectRef idx="0">
-            <a:schemeClr val="accent1"/>
-          </a:effectRef>
-          <a:fontRef idx="minor">
-            <a:schemeClr val="lt1"/>
-          </a:fontRef>
-        </p:style>
-        <p:txBody>
-          <a:bodyPr rtlCol="0" anchor="ctr" wrap="square" lIns="177800" rIns="177800" tIns="101600" bIns="127000">
+        </p:spPr>
+        <p:txBody>
+          <a:bodyPr wrap="square" lIns="152400" rIns="152400" tIns="101600" bIns="101600">
             <a:noAutofit/>
           </a:bodyPr>
           <a:lstStyle/>
           <a:p>
-            <a:pPr algn="l">
-              <a:lnSpc>
-                <a:spcPts val="2201"/>
-              </a:lnSpc>
-              <a:spcBef>
-                <a:spcPts val="0"/>
-              </a:spcBef>
-              <a:spcAft>
-                <a:spcPts val="0"/>
-              </a:spcAft>
-              <a:buNone/>
-              <a:defRPr sz="1850" b="0">
-                <a:solidFill>
-                  <a:srgbClr val="303437"/>
-                </a:solidFill>
-                <a:latin typeface="Noto Sans"/>
-              </a:defRPr>
-            </a:pPr>
-            <a:r>
-              <a:rPr sz="1850" b="0" lang="ja-JP" altLang="en-US">
+            <a:pPr>
+              <a:lnSpc>
+                <a:spcPts val="2257"/>
+              </a:lnSpc>
+              <a:spcBef>
+                <a:spcPts val="0"/>
+              </a:spcBef>
+              <a:spcAft>
+                <a:spcPts val="0"/>
+              </a:spcAft>
+              <a:buNone/>
+            </a:pPr>
+            <a:r>
+              <a:rPr sz="1850" b="0" lang="ja-JP">
                 <a:solidFill>
                   <a:srgbClr val="303437"/>
                 </a:solidFill>
@@ -25614,189 +25683,29 @@
               <a:t>This film features two of my favorite guilty pleasures. Sure, the effects are laughable, the story confused, but just watching Hasselhoff in his Knight Rider days is always fun.</a:t>
             </a:r>
           </a:p>
-        </p:txBody>
-      </p:sp>
-      <p:sp>
-        <p:nvSpPr>
-          <p:cNvPr id="6" name="TextBox 5"/>
-          <p:cNvSpPr txBox="1"/>
-          <p:nvPr/>
-        </p:nvSpPr>
-        <p:spPr>
-          <a:xfrm>
-            <a:off x="594360" y="2747835"/>
-            <a:ext cx="7955279" cy="875347"/>
-          </a:xfrm>
-          <a:prstGeom prst="rect">
-            <a:avLst/>
-          </a:prstGeom>
-          <a:noFill/>
-        </p:spPr>
-        <p:txBody>
-          <a:bodyPr wrap="square" lIns="0" rIns="0" tIns="0" bIns="0">
-            <a:noAutofit/>
-          </a:bodyPr>
-          <a:lstStyle/>
-          <a:p>
-            <a:pPr algn="l">
-              <a:lnSpc>
-                <a:spcPct val="119000"/>
-              </a:lnSpc>
-              <a:spcBef>
-                <a:spcPts val="0"/>
-              </a:spcBef>
-              <a:spcAft>
-                <a:spcPts val="0"/>
-              </a:spcAft>
-              <a:buNone/>
-              <a:defRPr sz="1850" b="0">
-                <a:solidFill>
-                  <a:srgbClr val="303437"/>
-                </a:solidFill>
-                <a:latin typeface="Noto Sans"/>
-              </a:defRPr>
-            </a:pPr>
-            <a:r>
-              <a:rPr sz="1850" b="0" lang="ja-JP" altLang="en-US">
-                <a:solidFill>
-                  <a:srgbClr val="303437"/>
-                </a:solidFill>
-                <a:latin typeface="Noto Sans"/>
-                <a:ea typeface="Noto Sans CJK JP"/>
-                <a:cs typeface="Noto Sans"/>
-              </a:rPr>
-              <a:t>この映画には、好きだが人には少し言いにくい楽しみが二つある。確かに特殊効果は笑ってしまう出来で、話も混乱しているが、『ナイトライダー』時代のハッセルホフを見るだけでも楽しい。</a:t>
-            </a:r>
-          </a:p>
-        </p:txBody>
-      </p:sp>
-      <p:sp>
-        <p:nvSpPr>
-          <p:cNvPr id="7" name="sources"/>
-          <p:cNvSpPr txBox="1"/>
-          <p:nvPr/>
-        </p:nvSpPr>
-        <p:spPr>
-          <a:xfrm>
-            <a:off x="502920" y="4700016"/>
-            <a:ext cx="8183879" cy="530352"/>
-          </a:xfrm>
-          <a:prstGeom prst="rect">
-            <a:avLst/>
-          </a:prstGeom>
-          <a:noFill/>
-        </p:spPr>
-        <p:txBody>
-          <a:bodyPr wrap="square" lIns="0" rIns="0" tIns="0" bIns="0">
-            <a:noAutofit/>
-          </a:bodyPr>
-          <a:lstStyle/>
-          <a:p>
-            <a:pPr algn="l">
-              <a:lnSpc>
-                <a:spcPts val="940"/>
-              </a:lnSpc>
-              <a:spcBef>
-                <a:spcPts val="0"/>
-              </a:spcBef>
-              <a:spcAft>
-                <a:spcPts val="140"/>
-              </a:spcAft>
-              <a:buNone/>
-              <a:defRPr sz="810" b="0">
-                <a:solidFill>
-                  <a:srgbClr val="303437"/>
-                </a:solidFill>
-                <a:latin typeface="Noto Sans"/>
-              </a:defRPr>
-            </a:pPr>
-            <a:r>
-              <a:rPr sz="810" b="0" lang="ja-JP" altLang="en-US">
-                <a:solidFill>
-                  <a:srgbClr val="626669"/>
-                </a:solidFill>
-                <a:latin typeface="Noto Sans"/>
-                <a:ea typeface="Noto Sans CJK JP"/>
-                <a:cs typeface="Noto Sans"/>
-              </a:rPr>
-              <a:t>[1] stanfordnlp/imdb、改訂e6281661。2026-10-17参照。 testの0始まり行 61。</a:t>
-            </a:r>
-            <a:r>
-              <a:rPr sz="810" b="0" lang="ja-JP" altLang="en-US">
-                <a:solidFill>
-                  <a:srgbClr val="626669"/>
-                </a:solidFill>
-                <a:latin typeface="Noto Sans"/>
-                <a:ea typeface="Noto Sans CJK JP"/>
-                <a:cs typeface="Noto Sans"/>
-              </a:rPr>
-              <a:t>  </a:t>
-            </a:r>
-            <a:r>
-              <a:rPr sz="810" b="0" lang="ja-JP" altLang="en-US">
-                <a:solidFill>
-                  <a:srgbClr val="626669"/>
-                </a:solidFill>
-                <a:latin typeface="Noto Sans"/>
-                <a:ea typeface="Noto Sans CJK JP"/>
-                <a:cs typeface="Noto Sans"/>
-                <a:hlinkClick r:id="rId2"/>
-              </a:rPr>
-              <a:t>https://huggingface.co/datasets/stanfordnlp/imdb</a:t>
-            </a:r>
-          </a:p>
-        </p:txBody>
-      </p:sp>
-      <p:sp>
-        <p:nvSpPr>
-          <p:cNvPr id="8" name="example-answer"/>
-          <p:cNvSpPr txBox="1"/>
-          <p:nvPr/>
-        </p:nvSpPr>
-        <p:spPr>
-          <a:xfrm>
-            <a:off x="6766560" y="1344168"/>
-            <a:ext cx="1783080" cy="237744"/>
-          </a:xfrm>
-          <a:prstGeom prst="rect">
-            <a:avLst/>
-          </a:prstGeom>
-          <a:noFill/>
-        </p:spPr>
-        <p:txBody>
-          <a:bodyPr wrap="square" lIns="0" rIns="0" tIns="0" bIns="0">
-            <a:noAutofit/>
-          </a:bodyPr>
-          <a:lstStyle/>
-          <a:p>
-            <a:pPr algn="r">
-              <a:lnSpc>
-                <a:spcPct val="117000"/>
-              </a:lnSpc>
-              <a:spcBef>
-                <a:spcPts val="0"/>
-              </a:spcBef>
-              <a:spcAft>
-                <a:spcPts val="0"/>
-              </a:spcAft>
-              <a:buNone/>
-              <a:defRPr sz="1450" b="0">
-                <a:solidFill>
-                  <a:srgbClr val="303437"/>
-                </a:solidFill>
-                <a:latin typeface="Noto Sans"/>
-              </a:defRPr>
-            </a:pPr>
-            <a:r>
-              <a:rPr sz="1450" b="1" lang="ja-JP" altLang="en-US">
-                <a:solidFill>
-                  <a:srgbClr val="2C9100"/>
-                </a:solidFill>
-                <a:latin typeface="Noto Sans"/>
-                <a:ea typeface="Noto Sans CJK JP"/>
-                <a:cs typeface="Noto Sans"/>
-              </a:rPr>
-              <a:t>ラベル：否定的</a:t>
+          <a:p>
+            <a:pPr>
+              <a:lnSpc>
+                <a:spcPts val="2257"/>
+              </a:lnSpc>
+              <a:spcBef>
+                <a:spcPts val="0"/>
+              </a:spcBef>
+              <a:spcAft>
+                <a:spcPts val="0"/>
+              </a:spcAft>
+              <a:buNone/>
+            </a:pPr>
+            <a:r>
+              <a:rPr sz="1850" b="0" lang="ja-JP">
+                <a:solidFill>
+                  <a:srgbClr val="303437"/>
+                </a:solidFill>
+                <a:latin typeface="Noto Sans"/>
+                <a:ea typeface="Noto Sans CJK JP"/>
+                <a:cs typeface="Noto Sans"/>
+              </a:rPr>
+              <a:t>I especially like the old hotel they used to shoot this in, it added to what little suspense was mustered. Give it a 3.</a:t>
             </a:r>
           </a:p>
         </p:txBody>

</xml_diff>

<commit_message>
Improve imdb answer visibility and citation wording
</commit_message>
<xml_diff>
--- a/slides/datasets-in-10-minutes-imdb.pptx
+++ b/slides/datasets-in-10-minutes-imdb.pptx
@@ -8774,8 +8774,8 @@
         </p:nvSpPr>
         <p:spPr>
           <a:xfrm>
-            <a:off x="6766560" y="1344168"/>
-            <a:ext cx="1783080" cy="237744"/>
+            <a:off x="5303520" y="1216152"/>
+            <a:ext cx="3246120" cy="384048"/>
           </a:xfrm>
           <a:prstGeom prst="rect">
             <a:avLst/>
@@ -8783,14 +8783,14 @@
           <a:noFill/>
         </p:spPr>
         <p:txBody>
-          <a:bodyPr wrap="square" lIns="0" rIns="0" tIns="0" bIns="0">
+          <a:bodyPr wrap="none" lIns="0" rIns="0" tIns="0" bIns="0">
             <a:noAutofit/>
           </a:bodyPr>
           <a:lstStyle/>
           <a:p>
             <a:pPr algn="r">
               <a:lnSpc>
-                <a:spcPct val="117000"/>
+                <a:spcPts val="2640"/>
               </a:lnSpc>
               <a:spcBef>
                 <a:spcPts val="0"/>
@@ -8807,9 +8807,9 @@
               </a:defRPr>
             </a:pPr>
             <a:r>
-              <a:rPr sz="1450" b="1" lang="ja-JP" altLang="en-US">
-                <a:solidFill>
-                  <a:srgbClr val="2C9100"/>
+              <a:rPr sz="2200" b="1" lang="ja-JP" altLang="en-US">
+                <a:solidFill>
+                  <a:schemeClr val="accent1"/>
                 </a:solidFill>
                 <a:latin typeface="Noto Sans"/>
                 <a:ea typeface="Noto Sans CJK JP"/>
@@ -12799,7 +12799,7 @@
                 <a:ea typeface="Noto Sans CJK JP"/>
                 <a:cs typeface="Noto Sans"/>
               </a:rPr>
-              <a:t>論文Table 2のOur Dataset列。25,000件のテスト、線形SVMによる分類。</a:t>
+              <a:t>25,000件のテスト、線形SVMによる分類。</a:t>
             </a:r>
           </a:p>
         </p:txBody>
@@ -16938,8 +16938,8 @@
         </p:nvSpPr>
         <p:spPr>
           <a:xfrm>
-            <a:off x="6766560" y="1344168"/>
-            <a:ext cx="1783080" cy="237744"/>
+            <a:off x="5303520" y="1216152"/>
+            <a:ext cx="3246120" cy="384048"/>
           </a:xfrm>
           <a:prstGeom prst="rect">
             <a:avLst/>
@@ -16947,14 +16947,14 @@
           <a:noFill/>
         </p:spPr>
         <p:txBody>
-          <a:bodyPr wrap="square" lIns="0" rIns="0" tIns="0" bIns="0">
+          <a:bodyPr wrap="none" lIns="0" rIns="0" tIns="0" bIns="0">
             <a:noAutofit/>
           </a:bodyPr>
           <a:lstStyle/>
           <a:p>
             <a:pPr algn="r">
               <a:lnSpc>
-                <a:spcPct val="117000"/>
+                <a:spcPts val="2640"/>
               </a:lnSpc>
               <a:spcBef>
                 <a:spcPts val="0"/>
@@ -16971,9 +16971,9 @@
               </a:defRPr>
             </a:pPr>
             <a:r>
-              <a:rPr sz="1450" b="1" lang="ja-JP" altLang="en-US">
-                <a:solidFill>
-                  <a:srgbClr val="2C9100"/>
+              <a:rPr sz="2200" b="1" lang="ja-JP" altLang="en-US">
+                <a:solidFill>
+                  <a:schemeClr val="accent1"/>
                 </a:solidFill>
                 <a:latin typeface="Noto Sans"/>
                 <a:ea typeface="Noto Sans CJK JP"/>
@@ -17365,8 +17365,8 @@
         </p:nvSpPr>
         <p:spPr>
           <a:xfrm>
-            <a:off x="6766560" y="1344168"/>
-            <a:ext cx="1783080" cy="237744"/>
+            <a:off x="5303520" y="1216152"/>
+            <a:ext cx="3246120" cy="384048"/>
           </a:xfrm>
           <a:prstGeom prst="rect">
             <a:avLst/>
@@ -17374,14 +17374,14 @@
           <a:noFill/>
         </p:spPr>
         <p:txBody>
-          <a:bodyPr wrap="square" lIns="0" rIns="0" tIns="0" bIns="0">
+          <a:bodyPr wrap="none" lIns="0" rIns="0" tIns="0" bIns="0">
             <a:noAutofit/>
           </a:bodyPr>
           <a:lstStyle/>
           <a:p>
             <a:pPr algn="r">
               <a:lnSpc>
-                <a:spcPct val="117000"/>
+                <a:spcPts val="2640"/>
               </a:lnSpc>
               <a:spcBef>
                 <a:spcPts val="0"/>
@@ -17398,9 +17398,9 @@
               </a:defRPr>
             </a:pPr>
             <a:r>
-              <a:rPr sz="1450" b="1" lang="ja-JP" altLang="en-US">
-                <a:solidFill>
-                  <a:srgbClr val="2C9100"/>
+              <a:rPr sz="2200" b="1" lang="ja-JP" altLang="en-US">
+                <a:solidFill>
+                  <a:schemeClr val="accent1"/>
                 </a:solidFill>
                 <a:latin typeface="Noto Sans"/>
                 <a:ea typeface="Noto Sans CJK JP"/>
@@ -17792,8 +17792,8 @@
         </p:nvSpPr>
         <p:spPr>
           <a:xfrm>
-            <a:off x="6766560" y="1344168"/>
-            <a:ext cx="1783080" cy="237744"/>
+            <a:off x="5303520" y="1216152"/>
+            <a:ext cx="3246120" cy="384048"/>
           </a:xfrm>
           <a:prstGeom prst="rect">
             <a:avLst/>
@@ -17801,14 +17801,14 @@
           <a:noFill/>
         </p:spPr>
         <p:txBody>
-          <a:bodyPr wrap="square" lIns="0" rIns="0" tIns="0" bIns="0">
+          <a:bodyPr wrap="none" lIns="0" rIns="0" tIns="0" bIns="0">
             <a:noAutofit/>
           </a:bodyPr>
           <a:lstStyle/>
           <a:p>
             <a:pPr algn="r">
               <a:lnSpc>
-                <a:spcPct val="117000"/>
+                <a:spcPts val="2640"/>
               </a:lnSpc>
               <a:spcBef>
                 <a:spcPts val="0"/>
@@ -17825,9 +17825,9 @@
               </a:defRPr>
             </a:pPr>
             <a:r>
-              <a:rPr sz="1450" b="1" lang="ja-JP" altLang="en-US">
-                <a:solidFill>
-                  <a:srgbClr val="2C9100"/>
+              <a:rPr sz="2200" b="1" lang="ja-JP" altLang="en-US">
+                <a:solidFill>
+                  <a:schemeClr val="accent1"/>
                 </a:solidFill>
                 <a:latin typeface="Noto Sans"/>
                 <a:ea typeface="Noto Sans CJK JP"/>
@@ -18219,8 +18219,8 @@
         </p:nvSpPr>
         <p:spPr>
           <a:xfrm>
-            <a:off x="6766560" y="1344168"/>
-            <a:ext cx="1783080" cy="237744"/>
+            <a:off x="5303520" y="1216152"/>
+            <a:ext cx="3246120" cy="384048"/>
           </a:xfrm>
           <a:prstGeom prst="rect">
             <a:avLst/>
@@ -18228,14 +18228,14 @@
           <a:noFill/>
         </p:spPr>
         <p:txBody>
-          <a:bodyPr wrap="square" lIns="0" rIns="0" tIns="0" bIns="0">
+          <a:bodyPr wrap="none" lIns="0" rIns="0" tIns="0" bIns="0">
             <a:noAutofit/>
           </a:bodyPr>
           <a:lstStyle/>
           <a:p>
             <a:pPr algn="r">
               <a:lnSpc>
-                <a:spcPct val="117000"/>
+                <a:spcPts val="2640"/>
               </a:lnSpc>
               <a:spcBef>
                 <a:spcPts val="0"/>
@@ -18252,9 +18252,9 @@
               </a:defRPr>
             </a:pPr>
             <a:r>
-              <a:rPr sz="1450" b="1" lang="ja-JP" altLang="en-US">
-                <a:solidFill>
-                  <a:srgbClr val="2C9100"/>
+              <a:rPr sz="2200" b="1" lang="ja-JP" altLang="en-US">
+                <a:solidFill>
+                  <a:schemeClr val="accent1"/>
                 </a:solidFill>
                 <a:latin typeface="Noto Sans"/>
                 <a:ea typeface="Noto Sans CJK JP"/>
@@ -18646,8 +18646,8 @@
         </p:nvSpPr>
         <p:spPr>
           <a:xfrm>
-            <a:off x="6766560" y="1344168"/>
-            <a:ext cx="1783080" cy="237744"/>
+            <a:off x="5303520" y="1216152"/>
+            <a:ext cx="3246120" cy="384048"/>
           </a:xfrm>
           <a:prstGeom prst="rect">
             <a:avLst/>
@@ -18655,14 +18655,14 @@
           <a:noFill/>
         </p:spPr>
         <p:txBody>
-          <a:bodyPr wrap="square" lIns="0" rIns="0" tIns="0" bIns="0">
+          <a:bodyPr wrap="none" lIns="0" rIns="0" tIns="0" bIns="0">
             <a:noAutofit/>
           </a:bodyPr>
           <a:lstStyle/>
           <a:p>
             <a:pPr algn="r">
               <a:lnSpc>
-                <a:spcPct val="117000"/>
+                <a:spcPts val="2640"/>
               </a:lnSpc>
               <a:spcBef>
                 <a:spcPts val="0"/>
@@ -18679,9 +18679,9 @@
               </a:defRPr>
             </a:pPr>
             <a:r>
-              <a:rPr sz="1450" b="1" lang="ja-JP" altLang="en-US">
-                <a:solidFill>
-                  <a:srgbClr val="2C9100"/>
+              <a:rPr sz="2200" b="1" lang="ja-JP" altLang="en-US">
+                <a:solidFill>
+                  <a:schemeClr val="accent1"/>
                 </a:solidFill>
                 <a:latin typeface="Noto Sans"/>
                 <a:ea typeface="Noto Sans CJK JP"/>
@@ -19187,8 +19187,8 @@
         </p:nvSpPr>
         <p:spPr>
           <a:xfrm>
-            <a:off x="6766560" y="1344168"/>
-            <a:ext cx="1783080" cy="237744"/>
+            <a:off x="5303520" y="1216152"/>
+            <a:ext cx="3246120" cy="384048"/>
           </a:xfrm>
           <a:prstGeom prst="rect">
             <a:avLst/>
@@ -19196,14 +19196,14 @@
           <a:noFill/>
         </p:spPr>
         <p:txBody>
-          <a:bodyPr wrap="square" lIns="0" rIns="0" tIns="0" bIns="0">
+          <a:bodyPr wrap="none" lIns="0" rIns="0" tIns="0" bIns="0">
             <a:noAutofit/>
           </a:bodyPr>
           <a:lstStyle/>
           <a:p>
             <a:pPr algn="r">
               <a:lnSpc>
-                <a:spcPct val="117000"/>
+                <a:spcPts val="2640"/>
               </a:lnSpc>
               <a:spcBef>
                 <a:spcPts val="0"/>
@@ -19220,9 +19220,9 @@
               </a:defRPr>
             </a:pPr>
             <a:r>
-              <a:rPr sz="1450" b="1" lang="ja-JP" altLang="en-US">
-                <a:solidFill>
-                  <a:srgbClr val="2C9100"/>
+              <a:rPr sz="2200" b="1" lang="ja-JP" altLang="en-US">
+                <a:solidFill>
+                  <a:schemeClr val="accent1"/>
                 </a:solidFill>
                 <a:latin typeface="Noto Sans"/>
                 <a:ea typeface="Noto Sans CJK JP"/>
@@ -19614,8 +19614,8 @@
         </p:nvSpPr>
         <p:spPr>
           <a:xfrm>
-            <a:off x="6766560" y="1344168"/>
-            <a:ext cx="1783080" cy="237744"/>
+            <a:off x="5303520" y="1216152"/>
+            <a:ext cx="3246120" cy="384048"/>
           </a:xfrm>
           <a:prstGeom prst="rect">
             <a:avLst/>
@@ -19623,14 +19623,14 @@
           <a:noFill/>
         </p:spPr>
         <p:txBody>
-          <a:bodyPr wrap="square" lIns="0" rIns="0" tIns="0" bIns="0">
+          <a:bodyPr wrap="none" lIns="0" rIns="0" tIns="0" bIns="0">
             <a:noAutofit/>
           </a:bodyPr>
           <a:lstStyle/>
           <a:p>
             <a:pPr algn="r">
               <a:lnSpc>
-                <a:spcPct val="117000"/>
+                <a:spcPts val="2640"/>
               </a:lnSpc>
               <a:spcBef>
                 <a:spcPts val="0"/>
@@ -19647,9 +19647,9 @@
               </a:defRPr>
             </a:pPr>
             <a:r>
-              <a:rPr sz="1450" b="1" lang="ja-JP" altLang="en-US">
-                <a:solidFill>
-                  <a:srgbClr val="2C9100"/>
+              <a:rPr sz="2200" b="1" lang="ja-JP" altLang="en-US">
+                <a:solidFill>
+                  <a:schemeClr val="accent1"/>
                 </a:solidFill>
                 <a:latin typeface="Noto Sans"/>
                 <a:ea typeface="Noto Sans CJK JP"/>
@@ -20041,8 +20041,8 @@
         </p:nvSpPr>
         <p:spPr>
           <a:xfrm>
-            <a:off x="6766560" y="1344168"/>
-            <a:ext cx="1783080" cy="237744"/>
+            <a:off x="5303520" y="1216152"/>
+            <a:ext cx="3246120" cy="384048"/>
           </a:xfrm>
           <a:prstGeom prst="rect">
             <a:avLst/>
@@ -20050,14 +20050,14 @@
           <a:noFill/>
         </p:spPr>
         <p:txBody>
-          <a:bodyPr wrap="square" lIns="0" rIns="0" tIns="0" bIns="0">
+          <a:bodyPr wrap="none" lIns="0" rIns="0" tIns="0" bIns="0">
             <a:noAutofit/>
           </a:bodyPr>
           <a:lstStyle/>
           <a:p>
             <a:pPr algn="r">
               <a:lnSpc>
-                <a:spcPct val="117000"/>
+                <a:spcPts val="2640"/>
               </a:lnSpc>
               <a:spcBef>
                 <a:spcPts val="0"/>
@@ -20074,9 +20074,9 @@
               </a:defRPr>
             </a:pPr>
             <a:r>
-              <a:rPr sz="1450" b="1" lang="ja-JP" altLang="en-US">
-                <a:solidFill>
-                  <a:srgbClr val="2C9100"/>
+              <a:rPr sz="2200" b="1" lang="ja-JP" altLang="en-US">
+                <a:solidFill>
+                  <a:schemeClr val="accent1"/>
                 </a:solidFill>
                 <a:latin typeface="Noto Sans"/>
                 <a:ea typeface="Noto Sans CJK JP"/>
@@ -20468,8 +20468,8 @@
         </p:nvSpPr>
         <p:spPr>
           <a:xfrm>
-            <a:off x="6766560" y="1344168"/>
-            <a:ext cx="1783080" cy="237744"/>
+            <a:off x="5303520" y="1216152"/>
+            <a:ext cx="3246120" cy="384048"/>
           </a:xfrm>
           <a:prstGeom prst="rect">
             <a:avLst/>
@@ -20477,14 +20477,14 @@
           <a:noFill/>
         </p:spPr>
         <p:txBody>
-          <a:bodyPr wrap="square" lIns="0" rIns="0" tIns="0" bIns="0">
+          <a:bodyPr wrap="none" lIns="0" rIns="0" tIns="0" bIns="0">
             <a:noAutofit/>
           </a:bodyPr>
           <a:lstStyle/>
           <a:p>
             <a:pPr algn="r">
               <a:lnSpc>
-                <a:spcPct val="117000"/>
+                <a:spcPts val="2640"/>
               </a:lnSpc>
               <a:spcBef>
                 <a:spcPts val="0"/>
@@ -20501,9 +20501,9 @@
               </a:defRPr>
             </a:pPr>
             <a:r>
-              <a:rPr sz="1450" b="1" lang="ja-JP" altLang="en-US">
-                <a:solidFill>
-                  <a:srgbClr val="2C9100"/>
+              <a:rPr sz="2200" b="1" lang="ja-JP" altLang="en-US">
+                <a:solidFill>
+                  <a:schemeClr val="accent1"/>
                 </a:solidFill>
                 <a:latin typeface="Noto Sans"/>
                 <a:ea typeface="Noto Sans CJK JP"/>
@@ -20895,8 +20895,8 @@
         </p:nvSpPr>
         <p:spPr>
           <a:xfrm>
-            <a:off x="6766560" y="1344168"/>
-            <a:ext cx="1783080" cy="237744"/>
+            <a:off x="5303520" y="1216152"/>
+            <a:ext cx="3246120" cy="384048"/>
           </a:xfrm>
           <a:prstGeom prst="rect">
             <a:avLst/>
@@ -20904,14 +20904,14 @@
           <a:noFill/>
         </p:spPr>
         <p:txBody>
-          <a:bodyPr wrap="square" lIns="0" rIns="0" tIns="0" bIns="0">
+          <a:bodyPr wrap="none" lIns="0" rIns="0" tIns="0" bIns="0">
             <a:noAutofit/>
           </a:bodyPr>
           <a:lstStyle/>
           <a:p>
             <a:pPr algn="r">
               <a:lnSpc>
-                <a:spcPct val="117000"/>
+                <a:spcPts val="2640"/>
               </a:lnSpc>
               <a:spcBef>
                 <a:spcPts val="0"/>
@@ -20928,9 +20928,9 @@
               </a:defRPr>
             </a:pPr>
             <a:r>
-              <a:rPr sz="1450" b="1" lang="ja-JP" altLang="en-US">
-                <a:solidFill>
-                  <a:srgbClr val="2C9100"/>
+              <a:rPr sz="2200" b="1" lang="ja-JP" altLang="en-US">
+                <a:solidFill>
+                  <a:schemeClr val="accent1"/>
                 </a:solidFill>
                 <a:latin typeface="Noto Sans"/>
                 <a:ea typeface="Noto Sans CJK JP"/>
@@ -25033,8 +25033,8 @@
         </p:nvSpPr>
         <p:spPr>
           <a:xfrm>
-            <a:off x="6766560" y="1344168"/>
-            <a:ext cx="1783080" cy="237744"/>
+            <a:off x="5303520" y="1216152"/>
+            <a:ext cx="3246120" cy="384048"/>
           </a:xfrm>
           <a:prstGeom prst="rect">
             <a:avLst/>
@@ -25042,14 +25042,14 @@
           <a:noFill/>
         </p:spPr>
         <p:txBody>
-          <a:bodyPr wrap="square" lIns="0" rIns="0" tIns="0" bIns="0">
+          <a:bodyPr wrap="none" lIns="0" rIns="0" tIns="0" bIns="0">
             <a:noAutofit/>
           </a:bodyPr>
           <a:lstStyle/>
           <a:p>
             <a:pPr algn="r">
               <a:lnSpc>
-                <a:spcPct val="117000"/>
+                <a:spcPts val="2640"/>
               </a:lnSpc>
               <a:spcBef>
                 <a:spcPts val="0"/>
@@ -25066,9 +25066,9 @@
               </a:defRPr>
             </a:pPr>
             <a:r>
-              <a:rPr sz="1450" b="1" lang="ja-JP" altLang="en-US">
-                <a:solidFill>
-                  <a:srgbClr val="2C9100"/>
+              <a:rPr sz="2200" b="1" lang="ja-JP" altLang="en-US">
+                <a:solidFill>
+                  <a:schemeClr val="accent1"/>
                 </a:solidFill>
                 <a:latin typeface="Noto Sans"/>
                 <a:ea typeface="Noto Sans CJK JP"/>

</xml_diff>